<commit_message>
data-eng w1d2s1 — 4장 강조 카드 번호 정정(accent 3→2)
Co-Authored-By: Claude Opus 5.5 <noreply@anthropic.com>
</commit_message>
<xml_diff>
--- a/data-eng/decks/w1d2s1.pptx
+++ b/data-eng/decks/w1d2s1.pptx
@@ -8364,11 +8364,11 @@
             </a:avLst>
           </a:prstGeom>
           <a:solidFill>
-            <a:srgbClr val="FAFBFD"/>
+            <a:srgbClr val="0D2B5E"/>
           </a:solidFill>
           <a:ln w="9525">
             <a:solidFill>
-              <a:srgbClr val="DCE1E8"/>
+              <a:srgbClr val="0D2B5E"/>
             </a:solidFill>
           </a:ln>
           <a:effectLst/>
@@ -8441,7 +8441,7 @@
             <a:r>
               <a:rPr sz="2550" b="1">
                 <a:solidFill>
-                  <a:srgbClr val="E4EBF4"/>
+                  <a:srgbClr val="3B4B7C"/>
                 </a:solidFill>
                 <a:latin typeface="Pretendard"/>
                 <a:ea typeface="Pretendard"/>
@@ -8482,7 +8482,7 @@
             <a:r>
               <a:rPr sz="3150" b="1">
                 <a:solidFill>
-                  <a:srgbClr val="0D2B5E"/>
+                  <a:srgbClr val="FFFFFF"/>
                 </a:solidFill>
                 <a:latin typeface="Pretendard"/>
                 <a:ea typeface="Pretendard"/>
@@ -8503,7 +8503,7 @@
             <a:r>
               <a:rPr sz="2250" b="0">
                 <a:solidFill>
-                  <a:srgbClr val="3D3D3D"/>
+                  <a:srgbClr val="D9E2F0"/>
                 </a:solidFill>
                 <a:latin typeface="Pretendard"/>
                 <a:ea typeface="Pretendard"/>
@@ -8521,7 +8521,7 @@
             <a:r>
               <a:rPr sz="2250" b="0">
                 <a:solidFill>
-                  <a:srgbClr val="3D3D3D"/>
+                  <a:srgbClr val="D9E2F0"/>
                 </a:solidFill>
                 <a:latin typeface="Pretendard"/>
                 <a:ea typeface="Pretendard"/>

</xml_diff>